<commit_message>
Refine chart hierarchy and complete submission package
Co-authored-by: Cursor <cursoragent@cursor.com>
</commit_message>
<xml_diff>
--- a/presentation/slides.pptx
+++ b/presentation/slides.pptx
@@ -117,6 +117,1797 @@
     </a:lvl9pPr>
   </p:defaultTextStyle>
 </p:presentation>
+</file>
+
+<file path=ppt/notesMasters/notesMaster1.xml><?xml version="1.0" encoding="utf-8"?>
+<p:notesMaster xmlns:a="http://schemas.openxmlformats.org/drawingml/2006/main" xmlns:p="http://schemas.openxmlformats.org/presentationml/2006/main" xmlns:r="http://schemas.openxmlformats.org/officeDocument/2006/relationships">
+  <p:cSld>
+    <p:bg>
+      <p:bgRef idx="1001">
+        <a:schemeClr val="bg1"/>
+      </p:bgRef>
+    </p:bg>
+    <p:spTree>
+      <p:nvGrpSpPr>
+        <p:cNvPr id="1" name=""/>
+        <p:cNvGrpSpPr/>
+        <p:nvPr/>
+      </p:nvGrpSpPr>
+      <p:grpSpPr>
+        <a:xfrm>
+          <a:off x="0" y="0"/>
+          <a:ext cx="0" cy="0"/>
+          <a:chOff x="0" y="0"/>
+          <a:chExt cx="0" cy="0"/>
+        </a:xfrm>
+      </p:grpSpPr>
+      <p:sp>
+        <p:nvSpPr>
+          <p:cNvPr id="2" name="Header Placeholder 1"/>
+          <p:cNvSpPr>
+            <a:spLocks noGrp="1"/>
+          </p:cNvSpPr>
+          <p:nvPr>
+            <p:ph type="hdr" sz="quarter"/>
+          </p:nvPr>
+        </p:nvSpPr>
+        <p:spPr>
+          <a:xfrm>
+            <a:off x="0" y="0"/>
+            <a:ext cx="2971800" cy="457200"/>
+          </a:xfrm>
+          <a:prstGeom prst="rect">
+            <a:avLst/>
+          </a:prstGeom>
+        </p:spPr>
+        <p:txBody>
+          <a:bodyPr vert="horz" lIns="91440" tIns="45720" rIns="91440" bIns="45720" rtlCol="0"/>
+          <a:lstStyle>
+            <a:lvl1pPr algn="l">
+              <a:defRPr sz="1200"/>
+            </a:lvl1pPr>
+          </a:lstStyle>
+          <a:p>
+            <a:endParaRPr lang="en-US"/>
+          </a:p>
+        </p:txBody>
+      </p:sp>
+      <p:sp>
+        <p:nvSpPr>
+          <p:cNvPr id="3" name="Date Placeholder 2"/>
+          <p:cNvSpPr>
+            <a:spLocks noGrp="1"/>
+          </p:cNvSpPr>
+          <p:nvPr>
+            <p:ph type="dt" idx="1"/>
+          </p:nvPr>
+        </p:nvSpPr>
+        <p:spPr>
+          <a:xfrm>
+            <a:off x="3884613" y="0"/>
+            <a:ext cx="2971800" cy="457200"/>
+          </a:xfrm>
+          <a:prstGeom prst="rect">
+            <a:avLst/>
+          </a:prstGeom>
+        </p:spPr>
+        <p:txBody>
+          <a:bodyPr vert="horz" lIns="91440" tIns="45720" rIns="91440" bIns="45720" rtlCol="0"/>
+          <a:lstStyle>
+            <a:lvl1pPr algn="r">
+              <a:defRPr sz="1200"/>
+            </a:lvl1pPr>
+          </a:lstStyle>
+          <a:p>
+            <a:fld id="{0F89C1C7-3DCD-1040-A9CF-14679D8B5DDD}" type="datetimeFigureOut">
+              <a:rPr lang="en-US" smtClean="0"/>
+              <a:t>10/17/16</a:t>
+            </a:fld>
+            <a:endParaRPr lang="en-US"/>
+          </a:p>
+        </p:txBody>
+      </p:sp>
+      <p:sp>
+        <p:nvSpPr>
+          <p:cNvPr id="4" name="Slide Image Placeholder 3"/>
+          <p:cNvSpPr>
+            <a:spLocks noGrp="1" noRot="1" noChangeAspect="1"/>
+          </p:cNvSpPr>
+          <p:nvPr>
+            <p:ph type="sldImg" idx="2"/>
+          </p:nvPr>
+        </p:nvSpPr>
+        <p:spPr>
+          <a:xfrm>
+            <a:off x="1143000" y="685800"/>
+            <a:ext cx="4572000" cy="3429000"/>
+          </a:xfrm>
+          <a:prstGeom prst="rect">
+            <a:avLst/>
+          </a:prstGeom>
+          <a:noFill/>
+          <a:ln w="12700">
+            <a:solidFill>
+              <a:prstClr val="black"/>
+            </a:solidFill>
+          </a:ln>
+        </p:spPr>
+        <p:txBody>
+          <a:bodyPr vert="horz" lIns="91440" tIns="45720" rIns="91440" bIns="45720" rtlCol="0" anchor="ctr"/>
+          <a:lstStyle/>
+          <a:p>
+            <a:endParaRPr lang="en-US"/>
+          </a:p>
+        </p:txBody>
+      </p:sp>
+      <p:sp>
+        <p:nvSpPr>
+          <p:cNvPr id="5" name="Notes Placeholder 4"/>
+          <p:cNvSpPr>
+            <a:spLocks noGrp="1"/>
+          </p:cNvSpPr>
+          <p:nvPr>
+            <p:ph type="body" sz="quarter" idx="3"/>
+          </p:nvPr>
+        </p:nvSpPr>
+        <p:spPr>
+          <a:xfrm>
+            <a:off x="685800" y="4343400"/>
+            <a:ext cx="5486400" cy="4114800"/>
+          </a:xfrm>
+          <a:prstGeom prst="rect">
+            <a:avLst/>
+          </a:prstGeom>
+        </p:spPr>
+        <p:txBody>
+          <a:bodyPr vert="horz" lIns="91440" tIns="45720" rIns="91440" bIns="45720" rtlCol="0"/>
+          <a:lstStyle/>
+          <a:p>
+            <a:pPr lvl="0"/>
+            <a:r>
+              <a:rPr lang="en-US" smtClean="0"/>
+              <a:t>Click to edit Master text styles</a:t>
+            </a:r>
+          </a:p>
+          <a:p>
+            <a:pPr lvl="1"/>
+            <a:r>
+              <a:rPr lang="en-US" smtClean="0"/>
+              <a:t>Second level</a:t>
+            </a:r>
+          </a:p>
+          <a:p>
+            <a:pPr lvl="2"/>
+            <a:r>
+              <a:rPr lang="en-US" smtClean="0"/>
+              <a:t>Third level</a:t>
+            </a:r>
+          </a:p>
+          <a:p>
+            <a:pPr lvl="3"/>
+            <a:r>
+              <a:rPr lang="en-US" smtClean="0"/>
+              <a:t>Fourth level</a:t>
+            </a:r>
+          </a:p>
+          <a:p>
+            <a:pPr lvl="4"/>
+            <a:r>
+              <a:rPr lang="en-US" smtClean="0"/>
+              <a:t>Fifth level</a:t>
+            </a:r>
+            <a:endParaRPr lang="en-US"/>
+          </a:p>
+        </p:txBody>
+      </p:sp>
+      <p:sp>
+        <p:nvSpPr>
+          <p:cNvPr id="6" name="Footer Placeholder 5"/>
+          <p:cNvSpPr>
+            <a:spLocks noGrp="1"/>
+          </p:cNvSpPr>
+          <p:nvPr>
+            <p:ph type="ftr" sz="quarter" idx="4"/>
+          </p:nvPr>
+        </p:nvSpPr>
+        <p:spPr>
+          <a:xfrm>
+            <a:off x="0" y="8685213"/>
+            <a:ext cx="2971800" cy="457200"/>
+          </a:xfrm>
+          <a:prstGeom prst="rect">
+            <a:avLst/>
+          </a:prstGeom>
+        </p:spPr>
+        <p:txBody>
+          <a:bodyPr vert="horz" lIns="91440" tIns="45720" rIns="91440" bIns="45720" rtlCol="0" anchor="b"/>
+          <a:lstStyle>
+            <a:lvl1pPr algn="l">
+              <a:defRPr sz="1200"/>
+            </a:lvl1pPr>
+          </a:lstStyle>
+          <a:p>
+            <a:endParaRPr lang="en-US"/>
+          </a:p>
+        </p:txBody>
+      </p:sp>
+      <p:sp>
+        <p:nvSpPr>
+          <p:cNvPr id="7" name="Slide Number Placeholder 6"/>
+          <p:cNvSpPr>
+            <a:spLocks noGrp="1"/>
+          </p:cNvSpPr>
+          <p:nvPr>
+            <p:ph type="sldNum" sz="quarter" idx="5"/>
+          </p:nvPr>
+        </p:nvSpPr>
+        <p:spPr>
+          <a:xfrm>
+            <a:off x="3884613" y="8685213"/>
+            <a:ext cx="2971800" cy="457200"/>
+          </a:xfrm>
+          <a:prstGeom prst="rect">
+            <a:avLst/>
+          </a:prstGeom>
+        </p:spPr>
+        <p:txBody>
+          <a:bodyPr vert="horz" lIns="91440" tIns="45720" rIns="91440" bIns="45720" rtlCol="0" anchor="b"/>
+          <a:lstStyle>
+            <a:lvl1pPr algn="r">
+              <a:defRPr sz="1200"/>
+            </a:lvl1pPr>
+          </a:lstStyle>
+          <a:p>
+            <a:fld id="{BB5E49A5-4136-284D-997B-48E1D791AD67}" type="slidenum">
+              <a:rPr lang="en-US" smtClean="0"/>
+              <a:t>‹#›</a:t>
+            </a:fld>
+            <a:endParaRPr lang="en-US"/>
+          </a:p>
+        </p:txBody>
+      </p:sp>
+    </p:spTree>
+    <p:extLst>
+      <p:ext uri="{BB962C8B-B14F-4D97-AF65-F5344CB8AC3E}">
+        <p14:creationId xmlns:p14="http://schemas.microsoft.com/office/powerpoint/2010/main" val="2623252185"/>
+      </p:ext>
+    </p:extLst>
+  </p:cSld>
+  <p:clrMap bg1="lt1" tx1="dk1" bg2="lt2" tx2="dk2" accent1="accent1" accent2="accent2" accent3="accent3" accent4="accent4" accent5="accent5" accent6="accent6" hlink="hlink" folHlink="folHlink"/>
+  <p:notesStyle>
+    <a:lvl1pPr marL="0" algn="l" defTabSz="457200" rtl="0" eaLnBrk="1" latinLnBrk="0" hangingPunct="1">
+      <a:defRPr sz="1200" kern="1200">
+        <a:solidFill>
+          <a:schemeClr val="tx1"/>
+        </a:solidFill>
+        <a:latin typeface="+mn-lt"/>
+        <a:ea typeface="+mn-ea"/>
+        <a:cs typeface="+mn-cs"/>
+      </a:defRPr>
+    </a:lvl1pPr>
+    <a:lvl2pPr marL="457200" algn="l" defTabSz="457200" rtl="0" eaLnBrk="1" latinLnBrk="0" hangingPunct="1">
+      <a:defRPr sz="1200" kern="1200">
+        <a:solidFill>
+          <a:schemeClr val="tx1"/>
+        </a:solidFill>
+        <a:latin typeface="+mn-lt"/>
+        <a:ea typeface="+mn-ea"/>
+        <a:cs typeface="+mn-cs"/>
+      </a:defRPr>
+    </a:lvl2pPr>
+    <a:lvl3pPr marL="914400" algn="l" defTabSz="457200" rtl="0" eaLnBrk="1" latinLnBrk="0" hangingPunct="1">
+      <a:defRPr sz="1200" kern="1200">
+        <a:solidFill>
+          <a:schemeClr val="tx1"/>
+        </a:solidFill>
+        <a:latin typeface="+mn-lt"/>
+        <a:ea typeface="+mn-ea"/>
+        <a:cs typeface="+mn-cs"/>
+      </a:defRPr>
+    </a:lvl3pPr>
+    <a:lvl4pPr marL="1371600" algn="l" defTabSz="457200" rtl="0" eaLnBrk="1" latinLnBrk="0" hangingPunct="1">
+      <a:defRPr sz="1200" kern="1200">
+        <a:solidFill>
+          <a:schemeClr val="tx1"/>
+        </a:solidFill>
+        <a:latin typeface="+mn-lt"/>
+        <a:ea typeface="+mn-ea"/>
+        <a:cs typeface="+mn-cs"/>
+      </a:defRPr>
+    </a:lvl4pPr>
+    <a:lvl5pPr marL="1828800" algn="l" defTabSz="457200" rtl="0" eaLnBrk="1" latinLnBrk="0" hangingPunct="1">
+      <a:defRPr sz="1200" kern="1200">
+        <a:solidFill>
+          <a:schemeClr val="tx1"/>
+        </a:solidFill>
+        <a:latin typeface="+mn-lt"/>
+        <a:ea typeface="+mn-ea"/>
+        <a:cs typeface="+mn-cs"/>
+      </a:defRPr>
+    </a:lvl5pPr>
+    <a:lvl6pPr marL="2286000" algn="l" defTabSz="457200" rtl="0" eaLnBrk="1" latinLnBrk="0" hangingPunct="1">
+      <a:defRPr sz="1200" kern="1200">
+        <a:solidFill>
+          <a:schemeClr val="tx1"/>
+        </a:solidFill>
+        <a:latin typeface="+mn-lt"/>
+        <a:ea typeface="+mn-ea"/>
+        <a:cs typeface="+mn-cs"/>
+      </a:defRPr>
+    </a:lvl6pPr>
+    <a:lvl7pPr marL="2743200" algn="l" defTabSz="457200" rtl="0" eaLnBrk="1" latinLnBrk="0" hangingPunct="1">
+      <a:defRPr sz="1200" kern="1200">
+        <a:solidFill>
+          <a:schemeClr val="tx1"/>
+        </a:solidFill>
+        <a:latin typeface="+mn-lt"/>
+        <a:ea typeface="+mn-ea"/>
+        <a:cs typeface="+mn-cs"/>
+      </a:defRPr>
+    </a:lvl7pPr>
+    <a:lvl8pPr marL="3200400" algn="l" defTabSz="457200" rtl="0" eaLnBrk="1" latinLnBrk="0" hangingPunct="1">
+      <a:defRPr sz="1200" kern="1200">
+        <a:solidFill>
+          <a:schemeClr val="tx1"/>
+        </a:solidFill>
+        <a:latin typeface="+mn-lt"/>
+        <a:ea typeface="+mn-ea"/>
+        <a:cs typeface="+mn-cs"/>
+      </a:defRPr>
+    </a:lvl8pPr>
+    <a:lvl9pPr marL="3657600" algn="l" defTabSz="457200" rtl="0" eaLnBrk="1" latinLnBrk="0" hangingPunct="1">
+      <a:defRPr sz="1200" kern="1200">
+        <a:solidFill>
+          <a:schemeClr val="tx1"/>
+        </a:solidFill>
+        <a:latin typeface="+mn-lt"/>
+        <a:ea typeface="+mn-ea"/>
+        <a:cs typeface="+mn-cs"/>
+      </a:defRPr>
+    </a:lvl9pPr>
+  </p:notesStyle>
+</p:notesMaster>
+</file>
+
+<file path=ppt/notesSlides/notesSlide1.xml><?xml version="1.0" encoding="utf-8"?>
+<p:notes xmlns:a="http://schemas.openxmlformats.org/drawingml/2006/main" xmlns:p="http://schemas.openxmlformats.org/presentationml/2006/main" xmlns:r="http://schemas.openxmlformats.org/officeDocument/2006/relationships">
+  <p:cSld>
+    <p:spTree>
+      <p:nvGrpSpPr>
+        <p:cNvPr id="1" name=""/>
+        <p:cNvGrpSpPr/>
+        <p:nvPr/>
+      </p:nvGrpSpPr>
+      <p:grpSpPr>
+        <a:xfrm>
+          <a:off x="0" y="0"/>
+          <a:ext cx="0" cy="0"/>
+          <a:chOff x="0" y="0"/>
+          <a:chExt cx="0" cy="0"/>
+        </a:xfrm>
+      </p:grpSpPr>
+      <p:sp>
+        <p:nvSpPr>
+          <p:cNvPr id="2" name="Slide Image Placeholder 1"/>
+          <p:cNvSpPr>
+            <a:spLocks noGrp="1"/>
+          </p:cNvSpPr>
+          <p:nvPr>
+            <p:ph type="sldImg" idx="2"/>
+          </p:nvPr>
+        </p:nvSpPr>
+        <p:spPr/>
+      </p:sp>
+      <p:sp>
+        <p:nvSpPr>
+          <p:cNvPr id="3" name="Notes Placeholder 2"/>
+          <p:cNvSpPr>
+            <a:spLocks noGrp="1"/>
+          </p:cNvSpPr>
+          <p:nvPr>
+            <p:ph type="body" idx="3" sz="quarter"/>
+          </p:nvPr>
+        </p:nvSpPr>
+        <p:spPr/>
+        <p:txBody>
+          <a:bodyPr/>
+          <a:lstStyle/>
+          <a:p>
+            <a:r>
+              <a:t>0:00–1:00 — Slide 1: Opening</a:t>
+            </a:r>
+          </a:p>
+          <a:p/>
+          <a:p>
+            <a:r>
+              <a:t>“My project is *The Renewable Grid, Hour by Hour*, a six-view interactive story built from 2025 EIA-930 operating data.”</a:t>
+            </a:r>
+          </a:p>
+          <a:p/>
+          <a:p>
+            <a:r>
+              <a:t>State the central question: how can a reader understand changes across a day, a year, and multiple regions without losing scale, variability, missingness, or methodological limits?</a:t>
+            </a:r>
+          </a:p>
+          <a:p/>
+          <a:p>
+            <a:r>
+              <a:t>Preview the argument: absolute output and renewable share tell different stories, and combining renewable sources can smooth some signals without always beating the steadiest component.</a:t>
+            </a:r>
+          </a:p>
+        </p:txBody>
+      </p:sp>
+      <p:sp>
+        <p:nvSpPr>
+          <p:cNvPr id="4" name="Slide Number Placeholder 3"/>
+          <p:cNvSpPr>
+            <a:spLocks noGrp="1"/>
+          </p:cNvSpPr>
+          <p:nvPr>
+            <p:ph type="sldNum" idx="5" sz="quarter"/>
+          </p:nvPr>
+        </p:nvSpPr>
+        <p:spPr/>
+      </p:sp>
+    </p:spTree>
+  </p:cSld>
+  <p:clrMapOvr>
+    <a:masterClrMapping/>
+  </p:clrMapOvr>
+</p:notes>
+</file>
+
+<file path=ppt/notesSlides/notesSlide10.xml><?xml version="1.0" encoding="utf-8"?>
+<p:notes xmlns:a="http://schemas.openxmlformats.org/drawingml/2006/main" xmlns:p="http://schemas.openxmlformats.org/presentationml/2006/main" xmlns:r="http://schemas.openxmlformats.org/officeDocument/2006/relationships">
+  <p:cSld>
+    <p:spTree>
+      <p:nvGrpSpPr>
+        <p:cNvPr id="1" name=""/>
+        <p:cNvGrpSpPr/>
+        <p:nvPr/>
+      </p:nvGrpSpPr>
+      <p:grpSpPr>
+        <a:xfrm>
+          <a:off x="0" y="0"/>
+          <a:ext cx="0" cy="0"/>
+          <a:chOff x="0" y="0"/>
+          <a:chExt cx="0" cy="0"/>
+        </a:xfrm>
+      </p:grpSpPr>
+      <p:sp>
+        <p:nvSpPr>
+          <p:cNvPr id="2" name="Slide Image Placeholder 1"/>
+          <p:cNvSpPr>
+            <a:spLocks noGrp="1"/>
+          </p:cNvSpPr>
+          <p:nvPr>
+            <p:ph type="sldImg" idx="2"/>
+          </p:nvPr>
+        </p:nvSpPr>
+        <p:spPr/>
+      </p:sp>
+      <p:sp>
+        <p:nvSpPr>
+          <p:cNvPr id="3" name="Notes Placeholder 2"/>
+          <p:cNvSpPr>
+            <a:spLocks noGrp="1"/>
+          </p:cNvSpPr>
+          <p:nvPr>
+            <p:ph type="body" idx="3" sz="quarter"/>
+          </p:nvPr>
+        </p:nvSpPr>
+        <p:spPr/>
+        <p:txBody>
+          <a:bodyPr/>
+          <a:lstStyle/>
+          <a:p>
+            <a:r>
+              <a:t>8:30–9:40 — Slide 10 + live View 6: Portfolio</a:t>
+            </a:r>
+          </a:p>
+          <a:p/>
+          <a:p>
+            <a:r>
+              <a:t>Before revealing the comparison, ask the class:</a:t>
+            </a:r>
+          </a:p>
+          <a:p/>
+          <a:p>
+            <a:r>
+              <a:t>&gt; If solar, wind, and hydropower are combined, will the portfolio always have the lowest coefficient of variation?</a:t>
+            </a:r>
+          </a:p>
+          <a:p/>
+          <a:p>
+            <a:r>
+              <a:t>Pause briefly for responses, then navigate to `#view-6`.</a:t>
+            </a:r>
+          </a:p>
+          <a:p/>
+          <a:p>
+            <a:r>
+              <a:t>1. Show all three selected sources.</a:t>
+            </a:r>
+          </a:p>
+          <a:p>
+            <a:r>
+              <a:t>2. Point to the combined daily-mean line.</a:t>
+            </a:r>
+          </a:p>
+          <a:p>
+            <a:r>
+              <a:t>3. Point to the CV comparison chart.</a:t>
+            </a:r>
+          </a:p>
+          <a:p>
+            <a:r>
+              <a:t>4. Toggle one source off, then use Reset sources.</a:t>
+            </a:r>
+          </a:p>
+          <a:p/>
+          <a:p>
+            <a:r>
+              <a:t>Finding: CISO 2025 CVs are solar 1.203, wind 0.595, hydropower 0.463, and combined 0.590. The portfolio is lower than solar and wind, but not lower than hydropower. The outcome depends on covariance, source choice, region, and period.</a:t>
+            </a:r>
+          </a:p>
+        </p:txBody>
+      </p:sp>
+      <p:sp>
+        <p:nvSpPr>
+          <p:cNvPr id="4" name="Slide Number Placeholder 3"/>
+          <p:cNvSpPr>
+            <a:spLocks noGrp="1"/>
+          </p:cNvSpPr>
+          <p:nvPr>
+            <p:ph type="sldNum" idx="5" sz="quarter"/>
+          </p:nvPr>
+        </p:nvSpPr>
+        <p:spPr/>
+      </p:sp>
+    </p:spTree>
+  </p:cSld>
+  <p:clrMapOvr>
+    <a:masterClrMapping/>
+  </p:clrMapOvr>
+</p:notes>
+</file>
+
+<file path=ppt/notesSlides/notesSlide11.xml><?xml version="1.0" encoding="utf-8"?>
+<p:notes xmlns:a="http://schemas.openxmlformats.org/drawingml/2006/main" xmlns:p="http://schemas.openxmlformats.org/presentationml/2006/main" xmlns:r="http://schemas.openxmlformats.org/officeDocument/2006/relationships">
+  <p:cSld>
+    <p:spTree>
+      <p:nvGrpSpPr>
+        <p:cNvPr id="1" name=""/>
+        <p:cNvGrpSpPr/>
+        <p:nvPr/>
+      </p:nvGrpSpPr>
+      <p:grpSpPr>
+        <a:xfrm>
+          <a:off x="0" y="0"/>
+          <a:ext cx="0" cy="0"/>
+          <a:chOff x="0" y="0"/>
+          <a:chExt cx="0" cy="0"/>
+        </a:xfrm>
+      </p:grpSpPr>
+      <p:sp>
+        <p:nvSpPr>
+          <p:cNvPr id="2" name="Slide Image Placeholder 1"/>
+          <p:cNvSpPr>
+            <a:spLocks noGrp="1"/>
+          </p:cNvSpPr>
+          <p:nvPr>
+            <p:ph type="sldImg" idx="2"/>
+          </p:nvPr>
+        </p:nvSpPr>
+        <p:spPr/>
+      </p:sp>
+      <p:sp>
+        <p:nvSpPr>
+          <p:cNvPr id="3" name="Notes Placeholder 2"/>
+          <p:cNvSpPr>
+            <a:spLocks noGrp="1"/>
+          </p:cNvSpPr>
+          <p:nvPr>
+            <p:ph type="body" idx="3" sz="quarter"/>
+          </p:nvPr>
+        </p:nvSpPr>
+        <p:spPr/>
+        <p:txBody>
+          <a:bodyPr/>
+          <a:lstStyle/>
+          <a:p>
+            <a:r>
+              <a:t>9:40–10:40 — Slide 11: Main annual findings</a:t>
+            </a:r>
+          </a:p>
+          <a:p/>
+          <a:p>
+            <a:r>
+              <a:t>Return to slides.</a:t>
+            </a:r>
+          </a:p>
+          <a:p/>
+          <a:p>
+            <a:r>
+              <a:t>- ERCO: 182.821 million MWh renewables, the largest absolute output; 37.583% share.</a:t>
+            </a:r>
+          </a:p>
+          <a:p>
+            <a:r>
+              <a:t>- CISO: 90.819 million MWh; the largest share at 48.744%.</a:t>
+            </a:r>
+          </a:p>
+          <a:p>
+            <a:r>
+              <a:t>- NYIS: 31.137 million MWh; 23.500%.</a:t>
+            </a:r>
+          </a:p>
+          <a:p>
+            <a:r>
+              <a:t>- PJM: 72.299 million MWh; 8.255%.</a:t>
+            </a:r>
+          </a:p>
+          <a:p/>
+          <a:p>
+            <a:r>
+              <a:t>Explain why this matters: PJM exceeds NYIS in absolute renewable energy but has a much lower share because its net generation is much larger. A single ranking cannot answer both scale and composition questions.</a:t>
+            </a:r>
+          </a:p>
+        </p:txBody>
+      </p:sp>
+      <p:sp>
+        <p:nvSpPr>
+          <p:cNvPr id="4" name="Slide Number Placeholder 3"/>
+          <p:cNvSpPr>
+            <a:spLocks noGrp="1"/>
+          </p:cNvSpPr>
+          <p:nvPr>
+            <p:ph type="sldNum" idx="5" sz="quarter"/>
+          </p:nvPr>
+        </p:nvSpPr>
+        <p:spPr/>
+      </p:sp>
+    </p:spTree>
+  </p:cSld>
+  <p:clrMapOvr>
+    <a:masterClrMapping/>
+  </p:clrMapOvr>
+</p:notes>
+</file>
+
+<file path=ppt/notesSlides/notesSlide12.xml><?xml version="1.0" encoding="utf-8"?>
+<p:notes xmlns:a="http://schemas.openxmlformats.org/drawingml/2006/main" xmlns:p="http://schemas.openxmlformats.org/presentationml/2006/main" xmlns:r="http://schemas.openxmlformats.org/officeDocument/2006/relationships">
+  <p:cSld>
+    <p:spTree>
+      <p:nvGrpSpPr>
+        <p:cNvPr id="1" name=""/>
+        <p:cNvGrpSpPr/>
+        <p:nvPr/>
+      </p:nvGrpSpPr>
+      <p:grpSpPr>
+        <a:xfrm>
+          <a:off x="0" y="0"/>
+          <a:ext cx="0" cy="0"/>
+          <a:chOff x="0" y="0"/>
+          <a:chExt cx="0" cy="0"/>
+        </a:xfrm>
+      </p:grpSpPr>
+      <p:sp>
+        <p:nvSpPr>
+          <p:cNvPr id="2" name="Slide Image Placeholder 1"/>
+          <p:cNvSpPr>
+            <a:spLocks noGrp="1"/>
+          </p:cNvSpPr>
+          <p:nvPr>
+            <p:ph type="sldImg" idx="2"/>
+          </p:nvPr>
+        </p:nvSpPr>
+        <p:spPr/>
+      </p:sp>
+      <p:sp>
+        <p:nvSpPr>
+          <p:cNvPr id="3" name="Notes Placeholder 2"/>
+          <p:cNvSpPr>
+            <a:spLocks noGrp="1"/>
+          </p:cNvSpPr>
+          <p:nvPr>
+            <p:ph type="body" idx="3" sz="quarter"/>
+          </p:nvPr>
+        </p:nvSpPr>
+        <p:spPr/>
+        <p:txBody>
+          <a:bodyPr/>
+          <a:lstStyle/>
+          <a:p>
+            <a:r>
+              <a:t>10:40–11:35 — Slide 12: Evaluation and limitations</a:t>
+            </a:r>
+          </a:p>
+          <a:p/>
+          <a:p>
+            <a:r>
+              <a:t>Completed evidence:</a:t>
+            </a:r>
+          </a:p>
+          <a:p/>
+          <a:p>
+            <a:r>
+              <a:t>- 20 automated tests;</a:t>
+            </a:r>
+          </a:p>
+          <a:p>
+            <a:r>
+              <a:t>- internal desktop and mobile rendering checks;</a:t>
+            </a:r>
+          </a:p>
+          <a:p>
+            <a:r>
+              <a:t>- playback and normalized-control checks; and</a:t>
+            </a:r>
+          </a:p>
+          <a:p>
+            <a:r>
+              <a:t>- six reproducible screenshots.</a:t>
+            </a:r>
+          </a:p>
+          <a:p/>
+          <a:p>
+            <a:r>
+              <a:t>Human evaluation:</a:t>
+            </a:r>
+          </a:p>
+          <a:p/>
+          <a:p>
+            <a:r>
+              <a:t>- one visual review identified overlapping chart titles and legends;</a:t>
+            </a:r>
+          </a:p>
+          <a:p>
+            <a:r>
+              <a:t>- the accepted revision separated title/legend zones, improved responsive spacing, and added a colorblind-safe palette; and</a:t>
+            </a:r>
+          </a:p>
+          <a:p>
+            <a:r>
+              <a:t>- a broader target-audience comprehension session remains pending.</a:t>
+            </a:r>
+          </a:p>
+          <a:p/>
+          <a:p>
+            <a:r>
+              <a:t>Key limitations: one year, four authorities, 31 renewable/mix gaps, authority-specific reporting, no capacity normalization, schematic map, and descriptive CV.</a:t>
+            </a:r>
+          </a:p>
+        </p:txBody>
+      </p:sp>
+      <p:sp>
+        <p:nvSpPr>
+          <p:cNvPr id="4" name="Slide Number Placeholder 3"/>
+          <p:cNvSpPr>
+            <a:spLocks noGrp="1"/>
+          </p:cNvSpPr>
+          <p:nvPr>
+            <p:ph type="sldNum" idx="5" sz="quarter"/>
+          </p:nvPr>
+        </p:nvSpPr>
+        <p:spPr/>
+      </p:sp>
+    </p:spTree>
+  </p:cSld>
+  <p:clrMapOvr>
+    <a:masterClrMapping/>
+  </p:clrMapOvr>
+</p:notes>
+</file>
+
+<file path=ppt/notesSlides/notesSlide13.xml><?xml version="1.0" encoding="utf-8"?>
+<p:notes xmlns:a="http://schemas.openxmlformats.org/drawingml/2006/main" xmlns:p="http://schemas.openxmlformats.org/presentationml/2006/main" xmlns:r="http://schemas.openxmlformats.org/officeDocument/2006/relationships">
+  <p:cSld>
+    <p:spTree>
+      <p:nvGrpSpPr>
+        <p:cNvPr id="1" name=""/>
+        <p:cNvGrpSpPr/>
+        <p:nvPr/>
+      </p:nvGrpSpPr>
+      <p:grpSpPr>
+        <a:xfrm>
+          <a:off x="0" y="0"/>
+          <a:ext cx="0" cy="0"/>
+          <a:chOff x="0" y="0"/>
+          <a:chExt cx="0" cy="0"/>
+        </a:xfrm>
+      </p:grpSpPr>
+      <p:sp>
+        <p:nvSpPr>
+          <p:cNvPr id="2" name="Slide Image Placeholder 1"/>
+          <p:cNvSpPr>
+            <a:spLocks noGrp="1"/>
+          </p:cNvSpPr>
+          <p:nvPr>
+            <p:ph type="sldImg" idx="2"/>
+          </p:nvPr>
+        </p:nvSpPr>
+        <p:spPr/>
+      </p:sp>
+      <p:sp>
+        <p:nvSpPr>
+          <p:cNvPr id="3" name="Notes Placeholder 2"/>
+          <p:cNvSpPr>
+            <a:spLocks noGrp="1"/>
+          </p:cNvSpPr>
+          <p:nvPr>
+            <p:ph type="body" idx="3" sz="quarter"/>
+          </p:nvPr>
+        </p:nvSpPr>
+        <p:spPr/>
+        <p:txBody>
+          <a:bodyPr/>
+          <a:lstStyle/>
+          <a:p>
+            <a:r>
+              <a:t>11:35–12:25 — Slide 13: Answer and contribution</a:t>
+            </a:r>
+          </a:p>
+          <a:p/>
+          <a:p>
+            <a:r>
+              <a:t>Answer the class question: no, a portfolio does not automatically have the lowest CV.</a:t>
+            </a:r>
+          </a:p>
+          <a:p/>
+          <a:p>
+            <a:r>
+              <a:t>Summarize the project contribution:</a:t>
+            </a:r>
+          </a:p>
+          <a:p/>
+          <a:p>
+            <a:r>
+              <a:t>- a coherent six-view explanatory sequence;</a:t>
+            </a:r>
+          </a:p>
+          <a:p>
+            <a:r>
+              <a:t>- reproducible source-to-figure workflow;</a:t>
+            </a:r>
+          </a:p>
+          <a:p>
+            <a:r>
+              <a:t>- explicit equations and boundary behavior;</a:t>
+            </a:r>
+          </a:p>
+          <a:p>
+            <a:r>
+              <a:t>- honest disclosure of failed validation and pending human testing.</a:t>
+            </a:r>
+          </a:p>
+          <a:p/>
+          <a:p>
+            <a:r>
+              <a:t>State that the Render URL has been verified and that the local app remains the presentation backup.</a:t>
+            </a:r>
+          </a:p>
+          <a:p/>
+          <a:p>
+            <a:r>
+              <a:t>12:25–13:00 — Close and questions</a:t>
+            </a:r>
+          </a:p>
+          <a:p/>
+          <a:p>
+            <a:r>
+              <a:t>Close with:</a:t>
+            </a:r>
+          </a:p>
+          <a:p/>
+          <a:p>
+            <a:r>
+              <a:t>“The key lesson is that renewable output has to be read in context: by hour, season, place, scale, and variability. The interface makes those comparisons available while keeping the missing data and analytical limits visible.”</a:t>
+            </a:r>
+          </a:p>
+          <a:p/>
+          <a:p>
+            <a:r>
+              <a:t>Invite questions.</a:t>
+            </a:r>
+          </a:p>
+        </p:txBody>
+      </p:sp>
+      <p:sp>
+        <p:nvSpPr>
+          <p:cNvPr id="4" name="Slide Number Placeholder 3"/>
+          <p:cNvSpPr>
+            <a:spLocks noGrp="1"/>
+          </p:cNvSpPr>
+          <p:nvPr>
+            <p:ph type="sldNum" idx="5" sz="quarter"/>
+          </p:nvPr>
+        </p:nvSpPr>
+        <p:spPr/>
+      </p:sp>
+    </p:spTree>
+  </p:cSld>
+  <p:clrMapOvr>
+    <a:masterClrMapping/>
+  </p:clrMapOvr>
+</p:notes>
+</file>
+
+<file path=ppt/notesSlides/notesSlide2.xml><?xml version="1.0" encoding="utf-8"?>
+<p:notes xmlns:a="http://schemas.openxmlformats.org/drawingml/2006/main" xmlns:p="http://schemas.openxmlformats.org/presentationml/2006/main" xmlns:r="http://schemas.openxmlformats.org/officeDocument/2006/relationships">
+  <p:cSld>
+    <p:spTree>
+      <p:nvGrpSpPr>
+        <p:cNvPr id="1" name=""/>
+        <p:cNvGrpSpPr/>
+        <p:nvPr/>
+      </p:nvGrpSpPr>
+      <p:grpSpPr>
+        <a:xfrm>
+          <a:off x="0" y="0"/>
+          <a:ext cx="0" cy="0"/>
+          <a:chOff x="0" y="0"/>
+          <a:chExt cx="0" cy="0"/>
+        </a:xfrm>
+      </p:grpSpPr>
+      <p:sp>
+        <p:nvSpPr>
+          <p:cNvPr id="2" name="Slide Image Placeholder 1"/>
+          <p:cNvSpPr>
+            <a:spLocks noGrp="1"/>
+          </p:cNvSpPr>
+          <p:nvPr>
+            <p:ph type="sldImg" idx="2"/>
+          </p:nvPr>
+        </p:nvSpPr>
+        <p:spPr/>
+      </p:sp>
+      <p:sp>
+        <p:nvSpPr>
+          <p:cNvPr id="3" name="Notes Placeholder 2"/>
+          <p:cNvSpPr>
+            <a:spLocks noGrp="1"/>
+          </p:cNvSpPr>
+          <p:nvPr>
+            <p:ph type="body" idx="3" sz="quarter"/>
+          </p:nvPr>
+        </p:nvSpPr>
+        <p:spPr/>
+        <p:txBody>
+          <a:bodyPr/>
+          <a:lstStyle/>
+          <a:p>
+            <a:r>
+              <a:t>1:00–2:00 — Slide 2: Audience and narrative design</a:t>
+            </a:r>
+          </a:p>
+          <a:p/>
+          <a:p>
+            <a:r>
+              <a:t>Identify the audience as students, instructors, and interested public readers with basic chart literacy.</a:t>
+            </a:r>
+          </a:p>
+          <a:p/>
+          <a:p>
+            <a:r>
+              <a:t>Explain the sequence:</a:t>
+            </a:r>
+          </a:p>
+          <a:p/>
+          <a:p>
+            <a:r>
+              <a:t>1. whole-system context;</a:t>
+            </a:r>
+          </a:p>
+          <a:p>
+            <a:r>
+              <a:t>2. one renewable day;</a:t>
+            </a:r>
+          </a:p>
+          <a:p>
+            <a:r>
+              <a:t>3. annual source patterns;</a:t>
+            </a:r>
+          </a:p>
+          <a:p>
+            <a:r>
+              <a:t>4. regional comparison;</a:t>
+            </a:r>
+          </a:p>
+          <a:p>
+            <a:r>
+              <a:t>5. numerical variability; and</a:t>
+            </a:r>
+          </a:p>
+          <a:p>
+            <a:r>
+              <a:t>6. portfolio complementarity.</a:t>
+            </a:r>
+          </a:p>
+          <a:p/>
+          <a:p>
+            <a:r>
+              <a:t>Emphasize that this is descriptive visualization—not a forecast, causal dispatch explanation, capacity-factor study, or reliability model.</a:t>
+            </a:r>
+          </a:p>
+        </p:txBody>
+      </p:sp>
+      <p:sp>
+        <p:nvSpPr>
+          <p:cNvPr id="4" name="Slide Number Placeholder 3"/>
+          <p:cNvSpPr>
+            <a:spLocks noGrp="1"/>
+          </p:cNvSpPr>
+          <p:nvPr>
+            <p:ph type="sldNum" idx="5" sz="quarter"/>
+          </p:nvPr>
+        </p:nvSpPr>
+        <p:spPr/>
+      </p:sp>
+    </p:spTree>
+  </p:cSld>
+  <p:clrMapOvr>
+    <a:masterClrMapping/>
+  </p:clrMapOvr>
+</p:notes>
+</file>
+
+<file path=ppt/notesSlides/notesSlide3.xml><?xml version="1.0" encoding="utf-8"?>
+<p:notes xmlns:a="http://schemas.openxmlformats.org/drawingml/2006/main" xmlns:p="http://schemas.openxmlformats.org/presentationml/2006/main" xmlns:r="http://schemas.openxmlformats.org/officeDocument/2006/relationships">
+  <p:cSld>
+    <p:spTree>
+      <p:nvGrpSpPr>
+        <p:cNvPr id="1" name=""/>
+        <p:cNvGrpSpPr/>
+        <p:nvPr/>
+      </p:nvGrpSpPr>
+      <p:grpSpPr>
+        <a:xfrm>
+          <a:off x="0" y="0"/>
+          <a:ext cx="0" cy="0"/>
+          <a:chOff x="0" y="0"/>
+          <a:chExt cx="0" cy="0"/>
+        </a:xfrm>
+      </p:grpSpPr>
+      <p:sp>
+        <p:nvSpPr>
+          <p:cNvPr id="2" name="Slide Image Placeholder 1"/>
+          <p:cNvSpPr>
+            <a:spLocks noGrp="1"/>
+          </p:cNvSpPr>
+          <p:nvPr>
+            <p:ph type="sldImg" idx="2"/>
+          </p:nvPr>
+        </p:nvSpPr>
+        <p:spPr/>
+      </p:sp>
+      <p:sp>
+        <p:nvSpPr>
+          <p:cNvPr id="3" name="Notes Placeholder 2"/>
+          <p:cNvSpPr>
+            <a:spLocks noGrp="1"/>
+          </p:cNvSpPr>
+          <p:nvPr>
+            <p:ph type="body" idx="3" sz="quarter"/>
+          </p:nvPr>
+        </p:nvSpPr>
+        <p:spPr/>
+        <p:txBody>
+          <a:bodyPr/>
+          <a:lstStyle/>
+          <a:p>
+            <a:r>
+              <a:t>2:00–3:10 — Slide 3: Preparation-code talking points</a:t>
+            </a:r>
+          </a:p>
+          <a:p/>
+          <a:p>
+            <a:r>
+              <a:t>Use these concise code-level points:</a:t>
+            </a:r>
+          </a:p>
+          <a:p/>
+          <a:p>
+            <a:r>
+              <a:t>- The source is a fixed Zenodo record of EIA Form 930, version 97.0.0.</a:t>
+            </a:r>
+          </a:p>
+          <a:p>
+            <a:r>
+              <a:t>- The download stage verifies published MD5 values and records SHA-256 checksums.</a:t>
+            </a:r>
+          </a:p>
+          <a:p>
+            <a:r>
+              <a:t>- Preparation filters CISO, ERCO, NYIS, and PJM.</a:t>
+            </a:r>
+          </a:p>
+          <a:p>
+            <a:r>
+              <a:t>- For each field, adjusted values are preferred, then imputed, then raw.</a:t>
+            </a:r>
+          </a:p>
+          <a:p>
+            <a:r>
+              <a:t>- Solar combines with- and without-integrated-battery reporting; wind does the same.</a:t>
+            </a:r>
+          </a:p>
+          <a:p>
+            <a:r>
+              <a:t>- Renewables equal solar + wind + hydropower excluding pumped storage.</a:t>
+            </a:r>
+          </a:p>
+          <a:p>
+            <a:r>
+              <a:t>- Standalone and pumped storage are excluded from the primary mix.</a:t>
+            </a:r>
+          </a:p>
+          <a:p>
+            <a:r>
+              <a:t>- One-hour average MW sums to MWh; daily curves are available-hour arithmetic means.</a:t>
+            </a:r>
+          </a:p>
+          <a:p>
+            <a:r>
+              <a:t>- Missing values remain gaps rather than being filled after preparation.</a:t>
+            </a:r>
+          </a:p>
+          <a:p/>
+          <a:p>
+            <a:r>
+              <a:t>Mention that the processed result is 35,040 rows: 8,760 per authority.</a:t>
+            </a:r>
+          </a:p>
+        </p:txBody>
+      </p:sp>
+      <p:sp>
+        <p:nvSpPr>
+          <p:cNvPr id="4" name="Slide Number Placeholder 3"/>
+          <p:cNvSpPr>
+            <a:spLocks noGrp="1"/>
+          </p:cNvSpPr>
+          <p:nvPr>
+            <p:ph type="sldNum" idx="5" sz="quarter"/>
+          </p:nvPr>
+        </p:nvSpPr>
+        <p:spPr/>
+      </p:sp>
+    </p:spTree>
+  </p:cSld>
+  <p:clrMapOvr>
+    <a:masterClrMapping/>
+  </p:clrMapOvr>
+</p:notes>
+</file>
+
+<file path=ppt/notesSlides/notesSlide4.xml><?xml version="1.0" encoding="utf-8"?>
+<p:notes xmlns:a="http://schemas.openxmlformats.org/drawingml/2006/main" xmlns:p="http://schemas.openxmlformats.org/presentationml/2006/main" xmlns:r="http://schemas.openxmlformats.org/officeDocument/2006/relationships">
+  <p:cSld>
+    <p:spTree>
+      <p:nvGrpSpPr>
+        <p:cNvPr id="1" name=""/>
+        <p:cNvGrpSpPr/>
+        <p:nvPr/>
+      </p:nvGrpSpPr>
+      <p:grpSpPr>
+        <a:xfrm>
+          <a:off x="0" y="0"/>
+          <a:ext cx="0" cy="0"/>
+          <a:chOff x="0" y="0"/>
+          <a:chExt cx="0" cy="0"/>
+        </a:xfrm>
+      </p:grpSpPr>
+      <p:sp>
+        <p:nvSpPr>
+          <p:cNvPr id="2" name="Slide Image Placeholder 1"/>
+          <p:cNvSpPr>
+            <a:spLocks noGrp="1"/>
+          </p:cNvSpPr>
+          <p:nvPr>
+            <p:ph type="sldImg" idx="2"/>
+          </p:nvPr>
+        </p:nvSpPr>
+        <p:spPr/>
+      </p:sp>
+      <p:sp>
+        <p:nvSpPr>
+          <p:cNvPr id="3" name="Notes Placeholder 2"/>
+          <p:cNvSpPr>
+            <a:spLocks noGrp="1"/>
+          </p:cNvSpPr>
+          <p:nvPr>
+            <p:ph type="body" idx="3" sz="quarter"/>
+          </p:nvPr>
+        </p:nvSpPr>
+        <p:spPr/>
+        <p:txBody>
+          <a:bodyPr/>
+          <a:lstStyle/>
+          <a:p>
+            <a:r>
+              <a:t>3:10–4:00 — Slide 4: Validation</a:t>
+            </a:r>
+          </a:p>
+          <a:p/>
+          <a:p>
+            <a:r>
+              <a:t>Say clearly: “Validation is not entirely clean.”</a:t>
+            </a:r>
+          </a:p>
+          <a:p/>
+          <a:p>
+            <a:r>
+              <a:t>- 10 of 11 persisted checks pass.</a:t>
+            </a:r>
+          </a:p>
+          <a:p>
+            <a:r>
+              <a:t>- Coverage, unique timestamps, hourly continuity, arithmetic, archive integrity, and versioned provenance pass.</a:t>
+            </a:r>
+          </a:p>
+          <a:p>
+            <a:r>
+              <a:t>- The required-values check fails.</a:t>
+            </a:r>
+          </a:p>
+          <a:p>
+            <a:r>
+              <a:t>- There are **31 missing renewable and generation-mix rows**, plus 25 missing demand and net-generation rows.</a:t>
+            </a:r>
+          </a:p>
+          <a:p>
+            <a:r>
+              <a:t>- The app reports missing values beside affected selections.</a:t>
+            </a:r>
+          </a:p>
+          <a:p/>
+          <a:p>
+            <a:r>
+              <a:t>Mention the 20 automated tests, but distinguish tests from audience evaluation.</a:t>
+            </a:r>
+          </a:p>
+        </p:txBody>
+      </p:sp>
+      <p:sp>
+        <p:nvSpPr>
+          <p:cNvPr id="4" name="Slide Number Placeholder 3"/>
+          <p:cNvSpPr>
+            <a:spLocks noGrp="1"/>
+          </p:cNvSpPr>
+          <p:nvPr>
+            <p:ph type="sldNum" idx="5" sz="quarter"/>
+          </p:nvPr>
+        </p:nvSpPr>
+        <p:spPr/>
+      </p:sp>
+    </p:spTree>
+  </p:cSld>
+  <p:clrMapOvr>
+    <a:masterClrMapping/>
+  </p:clrMapOvr>
+</p:notes>
+</file>
+
+<file path=ppt/notesSlides/notesSlide5.xml><?xml version="1.0" encoding="utf-8"?>
+<p:notes xmlns:a="http://schemas.openxmlformats.org/drawingml/2006/main" xmlns:p="http://schemas.openxmlformats.org/presentationml/2006/main" xmlns:r="http://schemas.openxmlformats.org/officeDocument/2006/relationships">
+  <p:cSld>
+    <p:spTree>
+      <p:nvGrpSpPr>
+        <p:cNvPr id="1" name=""/>
+        <p:cNvGrpSpPr/>
+        <p:nvPr/>
+      </p:nvGrpSpPr>
+      <p:grpSpPr>
+        <a:xfrm>
+          <a:off x="0" y="0"/>
+          <a:ext cx="0" cy="0"/>
+          <a:chOff x="0" y="0"/>
+          <a:chExt cx="0" cy="0"/>
+        </a:xfrm>
+      </p:grpSpPr>
+      <p:sp>
+        <p:nvSpPr>
+          <p:cNvPr id="2" name="Slide Image Placeholder 1"/>
+          <p:cNvSpPr>
+            <a:spLocks noGrp="1"/>
+          </p:cNvSpPr>
+          <p:nvPr>
+            <p:ph type="sldImg" idx="2"/>
+          </p:nvPr>
+        </p:nvSpPr>
+        <p:spPr/>
+      </p:sp>
+      <p:sp>
+        <p:nvSpPr>
+          <p:cNvPr id="3" name="Notes Placeholder 2"/>
+          <p:cNvSpPr>
+            <a:spLocks noGrp="1"/>
+          </p:cNvSpPr>
+          <p:nvPr>
+            <p:ph type="body" idx="3" sz="quarter"/>
+          </p:nvPr>
+        </p:nvSpPr>
+        <p:spPr/>
+        <p:txBody>
+          <a:bodyPr/>
+          <a:lstStyle/>
+          <a:p>
+            <a:r>
+              <a:t>4:00–4:50 — Slide 5 + live View 1: Generation mix</a:t>
+            </a:r>
+          </a:p>
+          <a:p/>
+          <a:p>
+            <a:r>
+              <a:t>Switch to the local application at &lt;http://127.0.0.1:8050/#view-1&gt;.</a:t>
+            </a:r>
+          </a:p>
+          <a:p/>
+          <a:p>
+            <a:r>
+              <a:t>Demo route:</a:t>
+            </a:r>
+          </a:p>
+          <a:p/>
+          <a:p>
+            <a:r>
+              <a:t>1. Confirm CISO and June 15, 2025.</a:t>
+            </a:r>
+          </a:p>
+          <a:p>
+            <a:r>
+              <a:t>2. Hover across the stacked mix.</a:t>
+            </a:r>
+          </a:p>
+          <a:p>
+            <a:r>
+              <a:t>3. Point to the takeaway and missing-data notice.</a:t>
+            </a:r>
+          </a:p>
+          <a:p>
+            <a:r>
+              <a:t>4. Briefly switch authority or date, then return to the default.</a:t>
+            </a:r>
+          </a:p>
+          <a:p/>
+          <a:p>
+            <a:r>
+              <a:t>Finding: solar has the largest summed hourly average on the default CISO day, about 35.1% of the positive reported mix. Explain that “positive reported mix” avoids allowing retained negative reports to distort the denominator.</a:t>
+            </a:r>
+          </a:p>
+        </p:txBody>
+      </p:sp>
+      <p:sp>
+        <p:nvSpPr>
+          <p:cNvPr id="4" name="Slide Number Placeholder 3"/>
+          <p:cNvSpPr>
+            <a:spLocks noGrp="1"/>
+          </p:cNvSpPr>
+          <p:nvPr>
+            <p:ph type="sldNum" idx="5" sz="quarter"/>
+          </p:nvPr>
+        </p:nvSpPr>
+        <p:spPr/>
+      </p:sp>
+    </p:spTree>
+  </p:cSld>
+  <p:clrMapOvr>
+    <a:masterClrMapping/>
+  </p:clrMapOvr>
+</p:notes>
+</file>
+
+<file path=ppt/notesSlides/notesSlide6.xml><?xml version="1.0" encoding="utf-8"?>
+<p:notes xmlns:a="http://schemas.openxmlformats.org/drawingml/2006/main" xmlns:p="http://schemas.openxmlformats.org/presentationml/2006/main" xmlns:r="http://schemas.openxmlformats.org/officeDocument/2006/relationships">
+  <p:cSld>
+    <p:spTree>
+      <p:nvGrpSpPr>
+        <p:cNvPr id="1" name=""/>
+        <p:cNvGrpSpPr/>
+        <p:nvPr/>
+      </p:nvGrpSpPr>
+      <p:grpSpPr>
+        <a:xfrm>
+          <a:off x="0" y="0"/>
+          <a:ext cx="0" cy="0"/>
+          <a:chOff x="0" y="0"/>
+          <a:chExt cx="0" cy="0"/>
+        </a:xfrm>
+      </p:grpSpPr>
+      <p:sp>
+        <p:nvSpPr>
+          <p:cNvPr id="2" name="Slide Image Placeholder 1"/>
+          <p:cNvSpPr>
+            <a:spLocks noGrp="1"/>
+          </p:cNvSpPr>
+          <p:nvPr>
+            <p:ph type="sldImg" idx="2"/>
+          </p:nvPr>
+        </p:nvSpPr>
+        <p:spPr/>
+      </p:sp>
+      <p:sp>
+        <p:nvSpPr>
+          <p:cNvPr id="3" name="Notes Placeholder 2"/>
+          <p:cNvSpPr>
+            <a:spLocks noGrp="1"/>
+          </p:cNvSpPr>
+          <p:nvPr>
+            <p:ph type="body" idx="3" sz="quarter"/>
+          </p:nvPr>
+        </p:nvSpPr>
+        <p:spPr/>
+        <p:txBody>
+          <a:bodyPr/>
+          <a:lstStyle/>
+          <a:p>
+            <a:r>
+              <a:t>4:50–5:40 — Slide 6 + live View 2: Hourly playback</a:t>
+            </a:r>
+          </a:p>
+          <a:p/>
+          <a:p>
+            <a:r>
+              <a:t>Navigate to `#view-2`.</a:t>
+            </a:r>
+          </a:p>
+          <a:p/>
+          <a:p>
+            <a:r>
+              <a:t>1. Click Reset.</a:t>
+            </a:r>
+          </a:p>
+          <a:p>
+            <a:r>
+              <a:t>2. Click Next twice.</a:t>
+            </a:r>
+          </a:p>
+          <a:p>
+            <a:r>
+              <a:t>3. Click Play, let several points appear, then Pause.</a:t>
+            </a:r>
+          </a:p>
+          <a:p>
+            <a:r>
+              <a:t>4. Drag the slider toward the last observation.</a:t>
+            </a:r>
+          </a:p>
+          <a:p/>
+          <a:p>
+            <a:r>
+              <a:t>Explain that the maximum is based on the selected day’s actual record count, supporting 23- and 25-observation daylight-saving days. Playback is clamped at both boundaries.</a:t>
+            </a:r>
+          </a:p>
+        </p:txBody>
+      </p:sp>
+      <p:sp>
+        <p:nvSpPr>
+          <p:cNvPr id="4" name="Slide Number Placeholder 3"/>
+          <p:cNvSpPr>
+            <a:spLocks noGrp="1"/>
+          </p:cNvSpPr>
+          <p:nvPr>
+            <p:ph type="sldNum" idx="5" sz="quarter"/>
+          </p:nvPr>
+        </p:nvSpPr>
+        <p:spPr/>
+      </p:sp>
+    </p:spTree>
+  </p:cSld>
+  <p:clrMapOvr>
+    <a:masterClrMapping/>
+  </p:clrMapOvr>
+</p:notes>
+</file>
+
+<file path=ppt/notesSlides/notesSlide7.xml><?xml version="1.0" encoding="utf-8"?>
+<p:notes xmlns:a="http://schemas.openxmlformats.org/drawingml/2006/main" xmlns:p="http://schemas.openxmlformats.org/presentationml/2006/main" xmlns:r="http://schemas.openxmlformats.org/officeDocument/2006/relationships">
+  <p:cSld>
+    <p:spTree>
+      <p:nvGrpSpPr>
+        <p:cNvPr id="1" name=""/>
+        <p:cNvGrpSpPr/>
+        <p:nvPr/>
+      </p:nvGrpSpPr>
+      <p:grpSpPr>
+        <a:xfrm>
+          <a:off x="0" y="0"/>
+          <a:ext cx="0" cy="0"/>
+          <a:chOff x="0" y="0"/>
+          <a:chExt cx="0" cy="0"/>
+        </a:xfrm>
+      </p:grpSpPr>
+      <p:sp>
+        <p:nvSpPr>
+          <p:cNvPr id="2" name="Slide Image Placeholder 1"/>
+          <p:cNvSpPr>
+            <a:spLocks noGrp="1"/>
+          </p:cNvSpPr>
+          <p:nvPr>
+            <p:ph type="sldImg" idx="2"/>
+          </p:nvPr>
+        </p:nvSpPr>
+        <p:spPr/>
+      </p:sp>
+      <p:sp>
+        <p:nvSpPr>
+          <p:cNvPr id="3" name="Notes Placeholder 2"/>
+          <p:cNvSpPr>
+            <a:spLocks noGrp="1"/>
+          </p:cNvSpPr>
+          <p:nvPr>
+            <p:ph type="body" idx="3" sz="quarter"/>
+          </p:nvPr>
+        </p:nvSpPr>
+        <p:spPr/>
+        <p:txBody>
+          <a:bodyPr/>
+          <a:lstStyle/>
+          <a:p>
+            <a:r>
+              <a:t>5:40–6:35 — Slide 7 + live View 3: Annual pulse</a:t>
+            </a:r>
+          </a:p>
+          <a:p/>
+          <a:p>
+            <a:r>
+              <a:t>Navigate to `#view-3`.</a:t>
+            </a:r>
+          </a:p>
+          <a:p/>
+          <a:p>
+            <a:r>
+              <a:t>1. Show all three sources in absolute mode.</a:t>
+            </a:r>
+          </a:p>
+          <a:p>
+            <a:r>
+              <a:t>2. Toggle individual source checkboxes.</a:t>
+            </a:r>
+          </a:p>
+          <a:p>
+            <a:r>
+              <a:t>3. Switch to Normalized.</a:t>
+            </a:r>
+          </a:p>
+          <a:p/>
+          <a:p>
+            <a:r>
+              <a:t>Say: “Each source is divided by its own annual peak. A value of 100% means that source’s peak, not equal MW and not renewable share.” Use the normalized mode to discuss shape and the absolute mode to discuss magnitude.</a:t>
+            </a:r>
+          </a:p>
+        </p:txBody>
+      </p:sp>
+      <p:sp>
+        <p:nvSpPr>
+          <p:cNvPr id="4" name="Slide Number Placeholder 3"/>
+          <p:cNvSpPr>
+            <a:spLocks noGrp="1"/>
+          </p:cNvSpPr>
+          <p:nvPr>
+            <p:ph type="sldNum" idx="5" sz="quarter"/>
+          </p:nvPr>
+        </p:nvSpPr>
+        <p:spPr/>
+      </p:sp>
+    </p:spTree>
+  </p:cSld>
+  <p:clrMapOvr>
+    <a:masterClrMapping/>
+  </p:clrMapOvr>
+</p:notes>
+</file>
+
+<file path=ppt/notesSlides/notesSlide8.xml><?xml version="1.0" encoding="utf-8"?>
+<p:notes xmlns:a="http://schemas.openxmlformats.org/drawingml/2006/main" xmlns:p="http://schemas.openxmlformats.org/presentationml/2006/main" xmlns:r="http://schemas.openxmlformats.org/officeDocument/2006/relationships">
+  <p:cSld>
+    <p:spTree>
+      <p:nvGrpSpPr>
+        <p:cNvPr id="1" name=""/>
+        <p:cNvGrpSpPr/>
+        <p:nvPr/>
+      </p:nvGrpSpPr>
+      <p:grpSpPr>
+        <a:xfrm>
+          <a:off x="0" y="0"/>
+          <a:ext cx="0" cy="0"/>
+          <a:chOff x="0" y="0"/>
+          <a:chExt cx="0" cy="0"/>
+        </a:xfrm>
+      </p:grpSpPr>
+      <p:sp>
+        <p:nvSpPr>
+          <p:cNvPr id="2" name="Slide Image Placeholder 1"/>
+          <p:cNvSpPr>
+            <a:spLocks noGrp="1"/>
+          </p:cNvSpPr>
+          <p:nvPr>
+            <p:ph type="sldImg" idx="2"/>
+          </p:nvPr>
+        </p:nvSpPr>
+        <p:spPr/>
+      </p:sp>
+      <p:sp>
+        <p:nvSpPr>
+          <p:cNvPr id="3" name="Notes Placeholder 2"/>
+          <p:cNvSpPr>
+            <a:spLocks noGrp="1"/>
+          </p:cNvSpPr>
+          <p:nvPr>
+            <p:ph type="body" idx="3" sz="quarter"/>
+          </p:nvPr>
+        </p:nvSpPr>
+        <p:spPr/>
+        <p:txBody>
+          <a:bodyPr/>
+          <a:lstStyle/>
+          <a:p>
+            <a:r>
+              <a:t>6:35–7:30 — Slide 8 + live View 4: Regional comparison</a:t>
+            </a:r>
+          </a:p>
+          <a:p/>
+          <a:p>
+            <a:r>
+              <a:t>Navigate to `#view-4`.</a:t>
+            </a:r>
+          </a:p>
+          <a:p/>
+          <a:p>
+            <a:r>
+              <a:t>1. Keep CISO and ERCO.</a:t>
+            </a:r>
+          </a:p>
+          <a:p>
+            <a:r>
+              <a:t>2. Keep solar and the full 2025 period.</a:t>
+            </a:r>
+          </a:p>
+          <a:p>
+            <a:r>
+              <a:t>3. Toggle Raw MW to Normalized and back.</a:t>
+            </a:r>
+          </a:p>
+          <a:p>
+            <a:r>
+              <a:t>4. Point out that both series use exactly the same operating dates.</a:t>
+            </a:r>
+          </a:p>
+          <a:p/>
+          <a:p>
+            <a:r>
+              <a:t>Finding: ERCO’s 2025 hourly mean solar is about 7,723.9 MW versus CISO’s 5,667.9 MW—about 1.36 times as high. Clarify that map points are schematic references, not balancing-authority boundaries.</a:t>
+            </a:r>
+          </a:p>
+        </p:txBody>
+      </p:sp>
+      <p:sp>
+        <p:nvSpPr>
+          <p:cNvPr id="4" name="Slide Number Placeholder 3"/>
+          <p:cNvSpPr>
+            <a:spLocks noGrp="1"/>
+          </p:cNvSpPr>
+          <p:nvPr>
+            <p:ph type="sldNum" idx="5" sz="quarter"/>
+          </p:nvPr>
+        </p:nvSpPr>
+        <p:spPr/>
+      </p:sp>
+    </p:spTree>
+  </p:cSld>
+  <p:clrMapOvr>
+    <a:masterClrMapping/>
+  </p:clrMapOvr>
+</p:notes>
+</file>
+
+<file path=ppt/notesSlides/notesSlide9.xml><?xml version="1.0" encoding="utf-8"?>
+<p:notes xmlns:a="http://schemas.openxmlformats.org/drawingml/2006/main" xmlns:p="http://schemas.openxmlformats.org/presentationml/2006/main" xmlns:r="http://schemas.openxmlformats.org/officeDocument/2006/relationships">
+  <p:cSld>
+    <p:spTree>
+      <p:nvGrpSpPr>
+        <p:cNvPr id="1" name=""/>
+        <p:cNvGrpSpPr/>
+        <p:nvPr/>
+      </p:nvGrpSpPr>
+      <p:grpSpPr>
+        <a:xfrm>
+          <a:off x="0" y="0"/>
+          <a:ext cx="0" cy="0"/>
+          <a:chOff x="0" y="0"/>
+          <a:chExt cx="0" cy="0"/>
+        </a:xfrm>
+      </p:grpSpPr>
+      <p:sp>
+        <p:nvSpPr>
+          <p:cNvPr id="2" name="Slide Image Placeholder 1"/>
+          <p:cNvSpPr>
+            <a:spLocks noGrp="1"/>
+          </p:cNvSpPr>
+          <p:nvPr>
+            <p:ph type="sldImg" idx="2"/>
+          </p:nvPr>
+        </p:nvSpPr>
+        <p:spPr/>
+      </p:sp>
+      <p:sp>
+        <p:nvSpPr>
+          <p:cNvPr id="3" name="Notes Placeholder 2"/>
+          <p:cNvSpPr>
+            <a:spLocks noGrp="1"/>
+          </p:cNvSpPr>
+          <p:nvPr>
+            <p:ph type="body" idx="3" sz="quarter"/>
+          </p:nvPr>
+        </p:nvSpPr>
+        <p:spPr/>
+        <p:txBody>
+          <a:bodyPr/>
+          <a:lstStyle/>
+          <a:p>
+            <a:r>
+              <a:t>7:30–8:30 — Slide 9 + live View 5: Variability</a:t>
+            </a:r>
+          </a:p>
+          <a:p/>
+          <a:p>
+            <a:r>
+              <a:t>Navigate to `#view-5`.</a:t>
+            </a:r>
+          </a:p>
+          <a:p/>
+          <a:p>
+            <a:r>
+              <a:t>Read selected CISO solar metrics:</a:t>
+            </a:r>
+          </a:p>
+          <a:p/>
+          <a:p>
+            <a:r>
+              <a:t>- mean: 5,667.9 MW;</a:t>
+            </a:r>
+          </a:p>
+          <a:p>
+            <a:r>
+              <a:t>- maximum: 18,912 MW;</a:t>
+            </a:r>
+          </a:p>
+          <a:p>
+            <a:r>
+              <a:t>- sample standard deviation: 6,818.2 MW; and</a:t>
+            </a:r>
+          </a:p>
+          <a:p>
+            <a:r>
+              <a:t>- CV: 1.203.</a:t>
+            </a:r>
+          </a:p>
+          <a:p/>
+          <a:p>
+            <a:r>
+              <a:t>Explain CV as sample standard deviation divided by the absolute mean. It compares relative spread, but it is not predictability, ramping difficulty, forecast error, or reliability. If the mean is zero—as with available NYIS solar values—the implemented result is “undefined.”</a:t>
+            </a:r>
+          </a:p>
+        </p:txBody>
+      </p:sp>
+      <p:sp>
+        <p:nvSpPr>
+          <p:cNvPr id="4" name="Slide Number Placeholder 3"/>
+          <p:cNvSpPr>
+            <a:spLocks noGrp="1"/>
+          </p:cNvSpPr>
+          <p:nvPr>
+            <p:ph type="sldNum" idx="5" sz="quarter"/>
+          </p:nvPr>
+        </p:nvSpPr>
+        <p:spPr/>
+      </p:sp>
+    </p:spTree>
+  </p:cSld>
+  <p:clrMapOvr>
+    <a:masterClrMapping/>
+  </p:clrMapOvr>
+</p:notes>
 </file>
 
 <file path=ppt/slideLayouts/slideLayout1.xml><?xml version="1.0" encoding="utf-8"?>
@@ -4210,7 +6001,7 @@
               </a:defRPr>
             </a:pPr>
             <a:r>
-              <a:t>Completed: 17 tests; internal desktop/mobile rendering; playback and normalized controls.</a:t>
+              <a:t>Completed: 20 tests; internal desktop/mobile checks; one visual-feedback revision.</a:t>
             </a:r>
           </a:p>
           <a:p>
@@ -4226,7 +6017,7 @@
               </a:defRPr>
             </a:pPr>
             <a:r>
-              <a:t>Pending: two target-audience sessions—no human feedback is claimed.</a:t>
+              <a:t>Pending: broader target-audience comprehension testing.</a:t>
             </a:r>
           </a:p>
           <a:p>
@@ -5643,7 +7434,7 @@
               </a:defRPr>
             </a:pPr>
             <a:r>
-              <a:t>17</a:t>
+              <a:t>20</a:t>
             </a:r>
           </a:p>
           <a:p>
@@ -7197,4 +8988,324 @@
   </a:objectDefaults>
   <a:extraClrSchemeLst/>
 </a:theme>
+</file>
+
+<file path=ppt/theme/theme2.xml><?xml version="1.0" encoding="utf-8"?>
+<a:theme xmlns:a="http://schemas.openxmlformats.org/drawingml/2006/main" name="Office Theme">
+  <a:themeElements>
+    <a:clrScheme name="Office">
+      <a:dk1>
+        <a:sysClr val="windowText" lastClr="000000"/>
+      </a:dk1>
+      <a:lt1>
+        <a:sysClr val="window" lastClr="FFFFFF"/>
+      </a:lt1>
+      <a:dk2>
+        <a:srgbClr val="1F497D"/>
+      </a:dk2>
+      <a:lt2>
+        <a:srgbClr val="EEECE1"/>
+      </a:lt2>
+      <a:accent1>
+        <a:srgbClr val="4F81BD"/>
+      </a:accent1>
+      <a:accent2>
+        <a:srgbClr val="C0504D"/>
+      </a:accent2>
+      <a:accent3>
+        <a:srgbClr val="9BBB59"/>
+      </a:accent3>
+      <a:accent4>
+        <a:srgbClr val="8064A2"/>
+      </a:accent4>
+      <a:accent5>
+        <a:srgbClr val="4BACC6"/>
+      </a:accent5>
+      <a:accent6>
+        <a:srgbClr val="F79646"/>
+      </a:accent6>
+      <a:hlink>
+        <a:srgbClr val="0000FF"/>
+      </a:hlink>
+      <a:folHlink>
+        <a:srgbClr val="800080"/>
+      </a:folHlink>
+    </a:clrScheme>
+    <a:fontScheme name="Office">
+      <a:majorFont>
+        <a:latin typeface="Calibri"/>
+        <a:ea typeface=""/>
+        <a:cs typeface=""/>
+        <a:font script="Jpan" typeface="ＭＳ Ｐゴシック"/>
+        <a:font script="Hang" typeface="맑은 고딕"/>
+        <a:font script="Hans" typeface="宋体"/>
+        <a:font script="Hant" typeface="新細明體"/>
+        <a:font script="Arab" typeface="Times New Roman"/>
+        <a:font script="Hebr" typeface="Times New Roman"/>
+        <a:font script="Thai" typeface="Angsana New"/>
+        <a:font script="Ethi" typeface="Nyala"/>
+        <a:font script="Beng" typeface="Vrinda"/>
+        <a:font script="Gujr" typeface="Shruti"/>
+        <a:font script="Khmr" typeface="MoolBoran"/>
+        <a:font script="Knda" typeface="Tunga"/>
+        <a:font script="Guru" typeface="Raavi"/>
+        <a:font script="Cans" typeface="Euphemia"/>
+        <a:font script="Cher" typeface="Plantagenet Cherokee"/>
+        <a:font script="Yiii" typeface="Microsoft Yi Baiti"/>
+        <a:font script="Tibt" typeface="Microsoft Himalaya"/>
+        <a:font script="Thaa" typeface="MV Boli"/>
+        <a:font script="Deva" typeface="Mangal"/>
+        <a:font script="Telu" typeface="Gautami"/>
+        <a:font script="Taml" typeface="Latha"/>
+        <a:font script="Syrc" typeface="Estrangelo Edessa"/>
+        <a:font script="Orya" typeface="Kalinga"/>
+        <a:font script="Mlym" typeface="Kartika"/>
+        <a:font script="Laoo" typeface="DokChampa"/>
+        <a:font script="Sinh" typeface="Iskoola Pota"/>
+        <a:font script="Mong" typeface="Mongolian Baiti"/>
+        <a:font script="Viet" typeface="Times New Roman"/>
+        <a:font script="Uigh" typeface="Microsoft Uighur"/>
+        <a:font script="Geor" typeface="Sylfaen"/>
+      </a:majorFont>
+      <a:minorFont>
+        <a:latin typeface="Calibri"/>
+        <a:ea typeface=""/>
+        <a:cs typeface=""/>
+        <a:font script="Jpan" typeface="ＭＳ Ｐゴシック"/>
+        <a:font script="Hang" typeface="맑은 고딕"/>
+        <a:font script="Hans" typeface="宋体"/>
+        <a:font script="Hant" typeface="新細明體"/>
+        <a:font script="Arab" typeface="Arial"/>
+        <a:font script="Hebr" typeface="Arial"/>
+        <a:font script="Thai" typeface="Cordia New"/>
+        <a:font script="Ethi" typeface="Nyala"/>
+        <a:font script="Beng" typeface="Vrinda"/>
+        <a:font script="Gujr" typeface="Shruti"/>
+        <a:font script="Khmr" typeface="DaunPenh"/>
+        <a:font script="Knda" typeface="Tunga"/>
+        <a:font script="Guru" typeface="Raavi"/>
+        <a:font script="Cans" typeface="Euphemia"/>
+        <a:font script="Cher" typeface="Plantagenet Cherokee"/>
+        <a:font script="Yiii" typeface="Microsoft Yi Baiti"/>
+        <a:font script="Tibt" typeface="Microsoft Himalaya"/>
+        <a:font script="Thaa" typeface="MV Boli"/>
+        <a:font script="Deva" typeface="Mangal"/>
+        <a:font script="Telu" typeface="Gautami"/>
+        <a:font script="Taml" typeface="Latha"/>
+        <a:font script="Syrc" typeface="Estrangelo Edessa"/>
+        <a:font script="Orya" typeface="Kalinga"/>
+        <a:font script="Mlym" typeface="Kartika"/>
+        <a:font script="Laoo" typeface="DokChampa"/>
+        <a:font script="Sinh" typeface="Iskoola Pota"/>
+        <a:font script="Mong" typeface="Mongolian Baiti"/>
+        <a:font script="Viet" typeface="Arial"/>
+        <a:font script="Uigh" typeface="Microsoft Uighur"/>
+        <a:font script="Geor" typeface="Sylfaen"/>
+      </a:minorFont>
+    </a:fontScheme>
+    <a:fmtScheme name="Office">
+      <a:fillStyleLst>
+        <a:solidFill>
+          <a:schemeClr val="phClr"/>
+        </a:solidFill>
+        <a:gradFill rotWithShape="1">
+          <a:gsLst>
+            <a:gs pos="0">
+              <a:schemeClr val="phClr">
+                <a:tint val="50000"/>
+                <a:satMod val="300000"/>
+              </a:schemeClr>
+            </a:gs>
+            <a:gs pos="35000">
+              <a:schemeClr val="phClr">
+                <a:tint val="37000"/>
+                <a:satMod val="300000"/>
+              </a:schemeClr>
+            </a:gs>
+            <a:gs pos="100000">
+              <a:schemeClr val="phClr">
+                <a:tint val="15000"/>
+                <a:satMod val="350000"/>
+              </a:schemeClr>
+            </a:gs>
+          </a:gsLst>
+          <a:lin ang="16200000" scaled="1"/>
+        </a:gradFill>
+        <a:gradFill rotWithShape="1">
+          <a:gsLst>
+            <a:gs pos="0">
+              <a:schemeClr val="phClr">
+                <a:tint val="100000"/>
+                <a:shade val="100000"/>
+                <a:satMod val="130000"/>
+              </a:schemeClr>
+            </a:gs>
+            <a:gs pos="100000">
+              <a:schemeClr val="phClr">
+                <a:tint val="50000"/>
+                <a:shade val="100000"/>
+                <a:satMod val="350000"/>
+              </a:schemeClr>
+            </a:gs>
+          </a:gsLst>
+          <a:lin ang="16200000" scaled="0"/>
+        </a:gradFill>
+      </a:fillStyleLst>
+      <a:lnStyleLst>
+        <a:ln w="9525" cap="flat" cmpd="sng" algn="ctr">
+          <a:solidFill>
+            <a:schemeClr val="phClr">
+              <a:shade val="95000"/>
+              <a:satMod val="105000"/>
+            </a:schemeClr>
+          </a:solidFill>
+          <a:prstDash val="solid"/>
+        </a:ln>
+        <a:ln w="25400" cap="flat" cmpd="sng" algn="ctr">
+          <a:solidFill>
+            <a:schemeClr val="phClr"/>
+          </a:solidFill>
+          <a:prstDash val="solid"/>
+        </a:ln>
+        <a:ln w="38100" cap="flat" cmpd="sng" algn="ctr">
+          <a:solidFill>
+            <a:schemeClr val="phClr"/>
+          </a:solidFill>
+          <a:prstDash val="solid"/>
+        </a:ln>
+      </a:lnStyleLst>
+      <a:effectStyleLst>
+        <a:effectStyle>
+          <a:effectLst>
+            <a:outerShdw blurRad="40000" dist="20000" dir="5400000" rotWithShape="0">
+              <a:srgbClr val="000000">
+                <a:alpha val="38000"/>
+              </a:srgbClr>
+            </a:outerShdw>
+          </a:effectLst>
+        </a:effectStyle>
+        <a:effectStyle>
+          <a:effectLst>
+            <a:outerShdw blurRad="40000" dist="23000" dir="5400000" rotWithShape="0">
+              <a:srgbClr val="000000">
+                <a:alpha val="35000"/>
+              </a:srgbClr>
+            </a:outerShdw>
+          </a:effectLst>
+        </a:effectStyle>
+        <a:effectStyle>
+          <a:effectLst>
+            <a:outerShdw blurRad="40000" dist="23000" dir="5400000" rotWithShape="0">
+              <a:srgbClr val="000000">
+                <a:alpha val="35000"/>
+              </a:srgbClr>
+            </a:outerShdw>
+          </a:effectLst>
+          <a:scene3d>
+            <a:camera prst="orthographicFront">
+              <a:rot lat="0" lon="0" rev="0"/>
+            </a:camera>
+            <a:lightRig rig="threePt" dir="t">
+              <a:rot lat="0" lon="0" rev="1200000"/>
+            </a:lightRig>
+          </a:scene3d>
+          <a:sp3d>
+            <a:bevelT w="63500" h="25400"/>
+          </a:sp3d>
+        </a:effectStyle>
+      </a:effectStyleLst>
+      <a:bgFillStyleLst>
+        <a:solidFill>
+          <a:schemeClr val="phClr"/>
+        </a:solidFill>
+        <a:gradFill rotWithShape="1">
+          <a:gsLst>
+            <a:gs pos="0">
+              <a:schemeClr val="phClr">
+                <a:tint val="40000"/>
+                <a:satMod val="350000"/>
+              </a:schemeClr>
+            </a:gs>
+            <a:gs pos="40000">
+              <a:schemeClr val="phClr">
+                <a:tint val="45000"/>
+                <a:shade val="99000"/>
+                <a:satMod val="350000"/>
+              </a:schemeClr>
+            </a:gs>
+            <a:gs pos="100000">
+              <a:schemeClr val="phClr">
+                <a:shade val="20000"/>
+                <a:satMod val="255000"/>
+              </a:schemeClr>
+            </a:gs>
+          </a:gsLst>
+          <a:path path="circle">
+            <a:fillToRect l="50000" t="-80000" r="50000" b="180000"/>
+          </a:path>
+        </a:gradFill>
+        <a:gradFill rotWithShape="1">
+          <a:gsLst>
+            <a:gs pos="0">
+              <a:schemeClr val="phClr">
+                <a:tint val="80000"/>
+                <a:satMod val="300000"/>
+              </a:schemeClr>
+            </a:gs>
+            <a:gs pos="100000">
+              <a:schemeClr val="phClr">
+                <a:shade val="30000"/>
+                <a:satMod val="200000"/>
+              </a:schemeClr>
+            </a:gs>
+          </a:gsLst>
+          <a:path path="circle">
+            <a:fillToRect l="50000" t="50000" r="50000" b="50000"/>
+          </a:path>
+        </a:gradFill>
+      </a:bgFillStyleLst>
+    </a:fmtScheme>
+  </a:themeElements>
+  <a:objectDefaults>
+    <a:spDef>
+      <a:spPr/>
+      <a:bodyPr/>
+      <a:lstStyle/>
+      <a:style>
+        <a:lnRef idx="1">
+          <a:schemeClr val="accent1"/>
+        </a:lnRef>
+        <a:fillRef idx="3">
+          <a:schemeClr val="accent1"/>
+        </a:fillRef>
+        <a:effectRef idx="2">
+          <a:schemeClr val="accent1"/>
+        </a:effectRef>
+        <a:fontRef idx="minor">
+          <a:schemeClr val="lt1"/>
+        </a:fontRef>
+      </a:style>
+    </a:spDef>
+    <a:lnDef>
+      <a:spPr/>
+      <a:bodyPr/>
+      <a:lstStyle/>
+      <a:style>
+        <a:lnRef idx="2">
+          <a:schemeClr val="accent1"/>
+        </a:lnRef>
+        <a:fillRef idx="0">
+          <a:schemeClr val="accent1"/>
+        </a:fillRef>
+        <a:effectRef idx="1">
+          <a:schemeClr val="accent1"/>
+        </a:effectRef>
+        <a:fontRef idx="minor">
+          <a:schemeClr val="tx1"/>
+        </a:fontRef>
+      </a:style>
+    </a:lnDef>
+  </a:objectDefaults>
+  <a:extraClrSchemeLst/>
+</a:theme>
 </file>
</xml_diff>

<commit_message>
Fix responsive chart legends and refresh submission
Co-authored-by: Cursor <cursoragent@cursor.com>
</commit_message>
<xml_diff>
--- a/presentation/slides.pptx
+++ b/presentation/slides.pptx
@@ -832,7 +832,7 @@
           <a:p/>
           <a:p>
             <a:r>
-              <a:t>- 20 automated tests;</a:t>
+              <a:t>- 21 automated tests;</a:t>
             </a:r>
           </a:p>
           <a:p>
@@ -1363,7 +1363,7 @@
           <a:p/>
           <a:p>
             <a:r>
-              <a:t>Mention the 20 automated tests, but distinguish tests from audience evaluation.</a:t>
+              <a:t>Mention the 21 automated tests, but distinguish tests from audience evaluation.</a:t>
             </a:r>
           </a:p>
         </p:txBody>
@@ -6001,7 +6001,7 @@
               </a:defRPr>
             </a:pPr>
             <a:r>
-              <a:t>Completed: 20 tests; internal desktop/mobile checks; one visual-feedback revision.</a:t>
+              <a:t>Completed: 21 tests; internal desktop/mobile checks; one visual-feedback revision.</a:t>
             </a:r>
           </a:p>
           <a:p>

</xml_diff>